<commit_message>
Enhance visual design across Report, Web Dashboard, and Presentation
- Embedded 6 publication-grade 300 DPI figures and benchmark tables into Word (.docx) & PDF reports
- Modernized Streamlit web application (app.py) with SVG circular score gauges, elevated card shadows, and official team roll numbers
- Upgraded Review 3 presentation (AI_News_Credibility_Scorer_Review3.pptx) with embedded architecture diagram, UI mockup, and graphical Gantt chart
- All 16 automated pytest unit tests passing
</commit_message>
<xml_diff>
--- a/docs/AI_News_Credibility_Scorer_Review3.pptx
+++ b/docs/AI_News_Credibility_Scorer_Review3.pptx
@@ -12518,661 +12518,30 @@
           </a:p>
         </p:txBody>
       </p:sp>
-      <p:sp>
-        <p:nvSpPr>
-          <p:cNvPr id="3" name="Rounded Rectangle 2"/>
-          <p:cNvSpPr/>
+      <p:pic>
+        <p:nvPicPr>
+          <p:cNvPr id="3" name="Picture 2" descr="fig3_1_architecture.png"/>
+          <p:cNvPicPr>
+            <a:picLocks noChangeAspect="1"/>
+          </p:cNvPicPr>
           <p:nvPr/>
-        </p:nvSpPr>
+        </p:nvPicPr>
+        <p:blipFill>
+          <a:blip r:embed="rId4"/>
+          <a:stretch>
+            <a:fillRect/>
+          </a:stretch>
+        </p:blipFill>
         <p:spPr>
           <a:xfrm>
-            <a:off x="731520" y="1280160"/>
-            <a:ext cx="3108960" cy="4846320"/>
+            <a:off x="731520" y="1234440"/>
+            <a:ext cx="10725912" cy="4892040"/>
           </a:xfrm>
-          <a:prstGeom prst="roundRect">
+          <a:prstGeom prst="rect">
             <a:avLst/>
           </a:prstGeom>
-          <a:solidFill>
-            <a:srgbClr val="F5F7FA"/>
-          </a:solidFill>
-          <a:ln w="19050">
-            <a:solidFill>
-              <a:srgbClr val="28A745"/>
-            </a:solidFill>
-          </a:ln>
         </p:spPr>
-        <p:style>
-          <a:lnRef idx="1">
-            <a:schemeClr val="accent1"/>
-          </a:lnRef>
-          <a:fillRef idx="3">
-            <a:schemeClr val="accent1"/>
-          </a:fillRef>
-          <a:effectRef idx="2">
-            <a:schemeClr val="accent1"/>
-          </a:effectRef>
-          <a:fontRef idx="minor">
-            <a:schemeClr val="lt1"/>
-          </a:fontRef>
-        </p:style>
-        <p:txBody>
-          <a:bodyPr rtlCol="0" anchor="ctr" wrap="square" lIns="109728" tIns="109728"/>
-          <a:lstStyle/>
-          <a:p>
-            <a:pPr algn="ctr">
-              <a:spcAft>
-                <a:spcPts val="600"/>
-              </a:spcAft>
-              <a:defRPr sz="1300" b="1">
-                <a:solidFill>
-                  <a:srgbClr val="28A745"/>
-                </a:solidFill>
-                <a:latin typeface="Arial"/>
-              </a:defRPr>
-            </a:pPr>
-            <a:r>
-              <a:t>1. Presentation Layer [LIVE]</a:t>
-            </a:r>
-          </a:p>
-          <a:p>
-            <a:pPr>
-              <a:spcAft>
-                <a:spcPts val="250"/>
-              </a:spcAft>
-              <a:defRPr sz="1050" b="1">
-                <a:solidFill>
-                  <a:srgbClr val="102C57"/>
-                </a:solidFill>
-                <a:latin typeface="Arial"/>
-              </a:defRPr>
-            </a:pPr>
-            <a:r>
-              <a:t>Streamlit Web Dashboard:</a:t>
-            </a:r>
-          </a:p>
-          <a:p>
-            <a:pPr>
-              <a:spcAft>
-                <a:spcPts val="250"/>
-              </a:spcAft>
-              <a:defRPr sz="1050" b="0">
-                <a:solidFill>
-                  <a:srgbClr val="212529"/>
-                </a:solidFill>
-                <a:latin typeface="Arial"/>
-              </a:defRPr>
-            </a:pPr>
-            <a:r>
-              <a:t> * Evaluator Login Portal</a:t>
-            </a:r>
-          </a:p>
-          <a:p>
-            <a:pPr>
-              <a:spcAft>
-                <a:spcPts val="250"/>
-              </a:spcAft>
-              <a:defRPr sz="1050" b="0">
-                <a:solidFill>
-                  <a:srgbClr val="212529"/>
-                </a:solidFill>
-                <a:latin typeface="Arial"/>
-              </a:defRPr>
-            </a:pPr>
-            <a:r>
-              <a:t> * 1-Click Desktop Launcher</a:t>
-            </a:r>
-          </a:p>
-          <a:p>
-            <a:pPr>
-              <a:spcAft>
-                <a:spcPts val="250"/>
-              </a:spcAft>
-              <a:defRPr sz="1050" b="0">
-                <a:solidFill>
-                  <a:srgbClr val="212529"/>
-                </a:solidFill>
-                <a:latin typeface="Arial"/>
-              </a:defRPr>
-            </a:pPr>
-          </a:p>
-          <a:p>
-            <a:pPr>
-              <a:spcAft>
-                <a:spcPts val="250"/>
-              </a:spcAft>
-              <a:defRPr sz="1050" b="1">
-                <a:solidFill>
-                  <a:srgbClr val="102C57"/>
-                </a:solidFill>
-                <a:latin typeface="Arial"/>
-              </a:defRPr>
-            </a:pPr>
-            <a:r>
-              <a:t>3 Verification Tabs:</a:t>
-            </a:r>
-          </a:p>
-          <a:p>
-            <a:pPr>
-              <a:spcAft>
-                <a:spcPts val="250"/>
-              </a:spcAft>
-              <a:defRPr sz="1050" b="0">
-                <a:solidFill>
-                  <a:srgbClr val="212529"/>
-                </a:solidFill>
-                <a:latin typeface="Arial"/>
-              </a:defRPr>
-            </a:pPr>
-            <a:r>
-              <a:t> * URL Domain Inspector</a:t>
-            </a:r>
-          </a:p>
-          <a:p>
-            <a:pPr>
-              <a:spcAft>
-                <a:spcPts val="250"/>
-              </a:spcAft>
-              <a:defRPr sz="1050" b="0">
-                <a:solidFill>
-                  <a:srgbClr val="212529"/>
-                </a:solidFill>
-                <a:latin typeface="Arial"/>
-              </a:defRPr>
-            </a:pPr>
-            <a:r>
-              <a:t> * Text Manipulation Scanner</a:t>
-            </a:r>
-          </a:p>
-          <a:p>
-            <a:pPr>
-              <a:spcAft>
-                <a:spcPts val="250"/>
-              </a:spcAft>
-              <a:defRPr sz="1050" b="0">
-                <a:solidFill>
-                  <a:srgbClr val="212529"/>
-                </a:solidFill>
-                <a:latin typeface="Arial"/>
-              </a:defRPr>
-            </a:pPr>
-            <a:r>
-              <a:t> * Live Claim Cross-Search</a:t>
-            </a:r>
-          </a:p>
-          <a:p>
-            <a:pPr>
-              <a:spcAft>
-                <a:spcPts val="250"/>
-              </a:spcAft>
-              <a:defRPr sz="1050" b="0">
-                <a:solidFill>
-                  <a:srgbClr val="212529"/>
-                </a:solidFill>
-                <a:latin typeface="Arial"/>
-              </a:defRPr>
-            </a:pPr>
-          </a:p>
-          <a:p>
-            <a:pPr>
-              <a:spcAft>
-                <a:spcPts val="250"/>
-              </a:spcAft>
-              <a:defRPr sz="1050" b="1">
-                <a:solidFill>
-                  <a:srgbClr val="102C57"/>
-                </a:solidFill>
-                <a:latin typeface="Arial"/>
-              </a:defRPr>
-            </a:pPr>
-            <a:r>
-              <a:t>Media Knowledge Directory:</a:t>
-            </a:r>
-          </a:p>
-          <a:p>
-            <a:pPr>
-              <a:spcAft>
-                <a:spcPts val="250"/>
-              </a:spcAft>
-              <a:defRPr sz="1050" b="0">
-                <a:solidFill>
-                  <a:srgbClr val="212529"/>
-                </a:solidFill>
-                <a:latin typeface="Arial"/>
-              </a:defRPr>
-            </a:pPr>
-            <a:r>
-              <a:t> * 4,442 Searchable Outlets</a:t>
-            </a:r>
-          </a:p>
-        </p:txBody>
-      </p:sp>
-      <p:sp>
-        <p:nvSpPr>
-          <p:cNvPr id="4" name="Rounded Rectangle 3"/>
-          <p:cNvSpPr/>
-          <p:nvPr/>
-        </p:nvSpPr>
-        <p:spPr>
-          <a:xfrm>
-            <a:off x="4206240" y="1280160"/>
-            <a:ext cx="3474720" cy="4846320"/>
-          </a:xfrm>
-          <a:prstGeom prst="roundRect">
-            <a:avLst/>
-          </a:prstGeom>
-          <a:solidFill>
-            <a:srgbClr val="F5F7FA"/>
-          </a:solidFill>
-          <a:ln w="19050">
-            <a:solidFill>
-              <a:srgbClr val="28A745"/>
-            </a:solidFill>
-          </a:ln>
-        </p:spPr>
-        <p:style>
-          <a:lnRef idx="1">
-            <a:schemeClr val="accent1"/>
-          </a:lnRef>
-          <a:fillRef idx="3">
-            <a:schemeClr val="accent1"/>
-          </a:fillRef>
-          <a:effectRef idx="2">
-            <a:schemeClr val="accent1"/>
-          </a:effectRef>
-          <a:fontRef idx="minor">
-            <a:schemeClr val="lt1"/>
-          </a:fontRef>
-        </p:style>
-        <p:txBody>
-          <a:bodyPr rtlCol="0" anchor="ctr" wrap="square" lIns="109728" tIns="109728"/>
-          <a:lstStyle/>
-          <a:p>
-            <a:pPr algn="ctr">
-              <a:spcAft>
-                <a:spcPts val="600"/>
-              </a:spcAft>
-              <a:defRPr sz="1300" b="1">
-                <a:solidFill>
-                  <a:srgbClr val="28A745"/>
-                </a:solidFill>
-                <a:latin typeface="Arial"/>
-              </a:defRPr>
-            </a:pPr>
-            <a:r>
-              <a:t>2. Retrieval &amp; Data Pipeline [LIVE]</a:t>
-            </a:r>
-          </a:p>
-          <a:p>
-            <a:pPr>
-              <a:spcAft>
-                <a:spcPts val="250"/>
-              </a:spcAft>
-              <a:defRPr sz="1050" b="1">
-                <a:solidFill>
-                  <a:srgbClr val="102C57"/>
-                </a:solidFill>
-                <a:latin typeface="Arial"/>
-              </a:defRPr>
-            </a:pPr>
-            <a:r>
-              <a:t>News Retrieval Engine:</a:t>
-            </a:r>
-          </a:p>
-          <a:p>
-            <a:pPr>
-              <a:spcAft>
-                <a:spcPts val="250"/>
-              </a:spcAft>
-              <a:defRPr sz="1050" b="0">
-                <a:solidFill>
-                  <a:srgbClr val="212529"/>
-                </a:solidFill>
-                <a:latin typeface="Arial"/>
-              </a:defRPr>
-            </a:pPr>
-            <a:r>
-              <a:t> * NewsAPI Live Integration</a:t>
-            </a:r>
-          </a:p>
-          <a:p>
-            <a:pPr>
-              <a:spcAft>
-                <a:spcPts val="250"/>
-              </a:spcAft>
-              <a:defRPr sz="1050" b="0">
-                <a:solidFill>
-                  <a:srgbClr val="212529"/>
-                </a:solidFill>
-                <a:latin typeface="Arial"/>
-              </a:defRPr>
-            </a:pPr>
-            <a:r>
-              <a:t> * GNews Backup Integration</a:t>
-            </a:r>
-          </a:p>
-          <a:p>
-            <a:pPr>
-              <a:spcAft>
-                <a:spcPts val="250"/>
-              </a:spcAft>
-              <a:defRPr sz="1050" b="0">
-                <a:solidFill>
-                  <a:srgbClr val="212529"/>
-                </a:solidFill>
-                <a:latin typeface="Arial"/>
-              </a:defRPr>
-            </a:pPr>
-            <a:r>
-              <a:t> * Corroboration Pool (5-10 Outlets)</a:t>
-            </a:r>
-          </a:p>
-          <a:p>
-            <a:pPr>
-              <a:spcAft>
-                <a:spcPts val="250"/>
-              </a:spcAft>
-              <a:defRPr sz="1050" b="0">
-                <a:solidFill>
-                  <a:srgbClr val="212529"/>
-                </a:solidFill>
-                <a:latin typeface="Arial"/>
-              </a:defRPr>
-            </a:pPr>
-          </a:p>
-          <a:p>
-            <a:pPr>
-              <a:spcAft>
-                <a:spcPts val="250"/>
-              </a:spcAft>
-              <a:defRPr sz="1050" b="1">
-                <a:solidFill>
-                  <a:srgbClr val="102C57"/>
-                </a:solidFill>
-                <a:latin typeface="Arial"/>
-              </a:defRPr>
-            </a:pPr>
-            <a:r>
-              <a:t>MBFC SQLite Database:</a:t>
-            </a:r>
-          </a:p>
-          <a:p>
-            <a:pPr>
-              <a:spcAft>
-                <a:spcPts val="250"/>
-              </a:spcAft>
-              <a:defRPr sz="1050" b="0">
-                <a:solidFill>
-                  <a:srgbClr val="212529"/>
-                </a:solidFill>
-                <a:latin typeface="Arial"/>
-              </a:defRPr>
-            </a:pPr>
-            <a:r>
-              <a:t> * 4,442 Domains Indexed</a:t>
-            </a:r>
-          </a:p>
-          <a:p>
-            <a:pPr>
-              <a:spcAft>
-                <a:spcPts val="250"/>
-              </a:spcAft>
-              <a:defRPr sz="1050" b="0">
-                <a:solidFill>
-                  <a:srgbClr val="212529"/>
-                </a:solidFill>
-                <a:latin typeface="Arial"/>
-              </a:defRPr>
-            </a:pPr>
-            <a:r>
-              <a:t> * Canonical Domain Resolver</a:t>
-            </a:r>
-          </a:p>
-          <a:p>
-            <a:pPr>
-              <a:spcAft>
-                <a:spcPts val="250"/>
-              </a:spcAft>
-              <a:defRPr sz="1050" b="0">
-                <a:solidFill>
-                  <a:srgbClr val="212529"/>
-                </a:solidFill>
-                <a:latin typeface="Arial"/>
-              </a:defRPr>
-            </a:pPr>
-            <a:r>
-              <a:t> * &lt;0.02ms Query Latency</a:t>
-            </a:r>
-          </a:p>
-          <a:p>
-            <a:pPr>
-              <a:spcAft>
-                <a:spcPts val="250"/>
-              </a:spcAft>
-              <a:defRPr sz="1050" b="0">
-                <a:solidFill>
-                  <a:srgbClr val="212529"/>
-                </a:solidFill>
-                <a:latin typeface="Arial"/>
-              </a:defRPr>
-            </a:pPr>
-            <a:r>
-              <a:t> * Source Weights (W_rep)</a:t>
-            </a:r>
-          </a:p>
-        </p:txBody>
-      </p:sp>
-      <p:sp>
-        <p:nvSpPr>
-          <p:cNvPr id="5" name="Rounded Rectangle 4"/>
-          <p:cNvSpPr/>
-          <p:nvPr/>
-        </p:nvSpPr>
-        <p:spPr>
-          <a:xfrm>
-            <a:off x="8046720" y="1280160"/>
-            <a:ext cx="3200400" cy="4846320"/>
-          </a:xfrm>
-          <a:prstGeom prst="roundRect">
-            <a:avLst/>
-          </a:prstGeom>
-          <a:solidFill>
-            <a:srgbClr val="F5F7FA"/>
-          </a:solidFill>
-          <a:ln w="19050">
-            <a:solidFill>
-              <a:srgbClr val="3565A9"/>
-            </a:solidFill>
-          </a:ln>
-        </p:spPr>
-        <p:style>
-          <a:lnRef idx="1">
-            <a:schemeClr val="accent1"/>
-          </a:lnRef>
-          <a:fillRef idx="3">
-            <a:schemeClr val="accent1"/>
-          </a:fillRef>
-          <a:effectRef idx="2">
-            <a:schemeClr val="accent1"/>
-          </a:effectRef>
-          <a:fontRef idx="minor">
-            <a:schemeClr val="lt1"/>
-          </a:fontRef>
-        </p:style>
-        <p:txBody>
-          <a:bodyPr rtlCol="0" anchor="ctr" wrap="square" lIns="109728" tIns="109728"/>
-          <a:lstStyle/>
-          <a:p>
-            <a:pPr algn="ctr">
-              <a:spcAft>
-                <a:spcPts val="600"/>
-              </a:spcAft>
-              <a:defRPr sz="1300" b="1">
-                <a:solidFill>
-                  <a:srgbClr val="102C57"/>
-                </a:solidFill>
-                <a:latin typeface="Arial"/>
-              </a:defRPr>
-            </a:pPr>
-            <a:r>
-              <a:t>3. Intelligence &amp; Scoring</a:t>
-            </a:r>
-          </a:p>
-          <a:p>
-            <a:pPr>
-              <a:spcAft>
-                <a:spcPts val="250"/>
-              </a:spcAft>
-              <a:defRPr sz="1050" b="1">
-                <a:solidFill>
-                  <a:srgbClr val="102C57"/>
-                </a:solidFill>
-                <a:latin typeface="Arial"/>
-              </a:defRPr>
-            </a:pPr>
-            <a:r>
-              <a:t>Manipulation Detector [LIVE]:</a:t>
-            </a:r>
-          </a:p>
-          <a:p>
-            <a:pPr>
-              <a:spcAft>
-                <a:spcPts val="250"/>
-              </a:spcAft>
-              <a:defRPr sz="1050" b="0">
-                <a:solidFill>
-                  <a:srgbClr val="212529"/>
-                </a:solidFill>
-                <a:latin typeface="Arial"/>
-              </a:defRPr>
-            </a:pPr>
-            <a:r>
-              <a:t> * 109 Lexical Triggers</a:t>
-            </a:r>
-          </a:p>
-          <a:p>
-            <a:pPr>
-              <a:spcAft>
-                <a:spcPts val="250"/>
-              </a:spcAft>
-              <a:defRPr sz="1050" b="0">
-                <a:solidFill>
-                  <a:srgbClr val="212529"/>
-                </a:solidFill>
-                <a:latin typeface="Arial"/>
-              </a:defRPr>
-            </a:pPr>
-            <a:r>
-              <a:t> * Clickbait &amp; Panic Analyzer</a:t>
-            </a:r>
-          </a:p>
-          <a:p>
-            <a:pPr>
-              <a:spcAft>
-                <a:spcPts val="250"/>
-              </a:spcAft>
-              <a:defRPr sz="1050" b="0">
-                <a:solidFill>
-                  <a:srgbClr val="212529"/>
-                </a:solidFill>
-                <a:latin typeface="Arial"/>
-              </a:defRPr>
-            </a:pPr>
-            <a:r>
-              <a:t> * Text Highlight Generator</a:t>
-            </a:r>
-          </a:p>
-          <a:p>
-            <a:pPr>
-              <a:spcAft>
-                <a:spcPts val="250"/>
-              </a:spcAft>
-              <a:defRPr sz="1050" b="0">
-                <a:solidFill>
-                  <a:srgbClr val="212529"/>
-                </a:solidFill>
-                <a:latin typeface="Arial"/>
-              </a:defRPr>
-            </a:pPr>
-          </a:p>
-          <a:p>
-            <a:pPr>
-              <a:spcAft>
-                <a:spcPts val="250"/>
-              </a:spcAft>
-              <a:defRPr sz="1050" b="1">
-                <a:solidFill>
-                  <a:srgbClr val="102C57"/>
-                </a:solidFill>
-                <a:latin typeface="Arial"/>
-              </a:defRPr>
-            </a:pPr>
-            <a:r>
-              <a:t>RoBERTa-MNLI Engine [Phase 4]:</a:t>
-            </a:r>
-          </a:p>
-          <a:p>
-            <a:pPr>
-              <a:spcAft>
-                <a:spcPts val="250"/>
-              </a:spcAft>
-              <a:defRPr sz="1050" b="0">
-                <a:solidFill>
-                  <a:srgbClr val="212529"/>
-                </a:solidFill>
-                <a:latin typeface="Arial"/>
-              </a:defRPr>
-            </a:pPr>
-            <a:r>
-              <a:t> * Stance Inference (Phi_NLI)</a:t>
-            </a:r>
-          </a:p>
-          <a:p>
-            <a:pPr>
-              <a:spcAft>
-                <a:spcPts val="250"/>
-              </a:spcAft>
-              <a:defRPr sz="1050" b="0">
-                <a:solidFill>
-                  <a:srgbClr val="212529"/>
-                </a:solidFill>
-                <a:latin typeface="Arial"/>
-              </a:defRPr>
-            </a:pPr>
-            <a:r>
-              <a:t> * Agree / Disagree / Neutral</a:t>
-            </a:r>
-          </a:p>
-          <a:p>
-            <a:pPr>
-              <a:spcAft>
-                <a:spcPts val="250"/>
-              </a:spcAft>
-              <a:defRPr sz="1050" b="0">
-                <a:solidFill>
-                  <a:srgbClr val="212529"/>
-                </a:solidFill>
-                <a:latin typeface="Arial"/>
-              </a:defRPr>
-            </a:pPr>
-          </a:p>
-          <a:p>
-            <a:pPr>
-              <a:spcAft>
-                <a:spcPts val="250"/>
-              </a:spcAft>
-              <a:defRPr sz="1050" b="0">
-                <a:solidFill>
-                  <a:srgbClr val="212529"/>
-                </a:solidFill>
-                <a:latin typeface="Arial"/>
-              </a:defRPr>
-            </a:pPr>
-            <a:r>
-              <a:t>Multi-Factor Aggregator [Phase 5]</a:t>
-            </a:r>
-          </a:p>
-        </p:txBody>
-      </p:sp>
+      </p:pic>
     </p:spTree>
   </p:cSld>
   <p:clrMapOvr>
@@ -13451,7 +12820,7 @@
         <p:spPr>
           <a:xfrm>
             <a:off x="731520" y="1188720"/>
-            <a:ext cx="10789920" cy="5120640"/>
+            <a:ext cx="5394960" cy="5120640"/>
           </a:xfrm>
           <a:prstGeom prst="rect">
             <a:avLst/>
@@ -13467,130 +12836,154 @@
           <a:p>
             <a:pPr>
               <a:spcAft>
-                <a:spcPts val="400"/>
+                <a:spcPts val="250"/>
               </a:spcAft>
             </a:pPr>
             <a:r>
-              <a:rPr b="1" sz="1250">
+              <a:rPr b="1" sz="1100">
                 <a:solidFill>
                   <a:srgbClr val="102C57"/>
                 </a:solidFill>
               </a:rPr>
-              <a:t>1. Live Multi-Source News Retrieval (NewsAPI Integration):
+              <a:t>1. Live Multi-Source News Retrieval (NewsAPI):
 </a:t>
             </a:r>
             <a:r>
-              <a:rPr sz="1150">
+              <a:rPr sz="1000">
                 <a:solidFill>
                   <a:srgbClr val="212529"/>
                 </a:solidFill>
               </a:rPr>
-              <a:t>Engineered live retrieval pipeline querying 80,000+ global publications via NewsAPI. System constructs an independent evidence pool of 5-10 articles per claim with attached publisher credibility weights.
+              <a:t>Live NewsAPI querying across 80,000+ publications to construct an independent corroboration pool with publisher trust ratings.
 </a:t>
             </a:r>
           </a:p>
           <a:p>
             <a:pPr>
               <a:spcAft>
-                <a:spcPts val="400"/>
+                <a:spcPts val="250"/>
               </a:spcAft>
             </a:pPr>
             <a:r>
-              <a:rPr b="1" sz="1250">
+              <a:rPr b="1" sz="1100">
                 <a:solidFill>
                   <a:srgbClr val="102C57"/>
                 </a:solidFill>
               </a:rPr>
-              <a:t>2. Interactive Streamlit Web Application Dashboard:
+              <a:t>2. Interactive Streamlit Dashboard:
 </a:t>
             </a:r>
             <a:r>
-              <a:rPr sz="1150">
+              <a:rPr sz="1000">
                 <a:solidFill>
                   <a:srgbClr val="212529"/>
                 </a:solidFill>
               </a:rPr>
-              <a:t>Transformed CLI prototypes into a full-featured web portal with evaluator authentication, URL reputation inspector, text manipulation scanner with in-line word highlighting, and live claim cross-search.
+              <a:t>Evaluator authentication, URL inspector, text manipulation scanner with highlight spans, and live claim cross-search.
 </a:t>
             </a:r>
           </a:p>
           <a:p>
             <a:pPr>
               <a:spcAft>
-                <a:spcPts val="400"/>
+                <a:spcPts val="250"/>
               </a:spcAft>
             </a:pPr>
             <a:r>
-              <a:rPr b="1" sz="1250">
+              <a:rPr b="1" sz="1100">
                 <a:solidFill>
                   <a:srgbClr val="102C57"/>
                 </a:solidFill>
               </a:rPr>
-              <a:t>3. 4,442 Media Outlet Knowledge Explorer:
+              <a:t>3. 4,442 Media Outlet Knowledge Base:
 </a:t>
             </a:r>
             <a:r>
-              <a:rPr sz="1150">
+              <a:rPr sz="1000">
                 <a:solidFill>
                   <a:srgbClr val="212529"/>
                 </a:solidFill>
               </a:rPr>
-              <a:t>Built an interactive database search and filtering module allowing evaluators to search any global outlet and inspect its factuality rating, political bias, and satire/conspiracy status.
+              <a:t>Indexed SQLite catalog with search and filtering for factuality, bias, and satire flags.
 </a:t>
             </a:r>
           </a:p>
           <a:p>
             <a:pPr>
               <a:spcAft>
-                <a:spcPts val="400"/>
+                <a:spcPts val="250"/>
               </a:spcAft>
             </a:pPr>
             <a:r>
-              <a:rPr b="1" sz="1250">
+              <a:rPr b="1" sz="1100">
                 <a:solidFill>
                   <a:srgbClr val="102C57"/>
                 </a:solidFill>
               </a:rPr>
-              <a:t>4. Automated Quality Assurance &amp; 16 Passing Unit Tests:
+              <a:t>4. Automated QA (16/16 Unit Tests):
 </a:t>
             </a:r>
             <a:r>
-              <a:rPr sz="1150">
+              <a:rPr sz="1000">
                 <a:solidFill>
                   <a:srgbClr val="212529"/>
                 </a:solidFill>
               </a:rPr>
-              <a:t>16 out of 16 unit tests passing across domain resolution, lexical triggers, and retrieval pipeline via pytest.
+              <a:t>100% pytest pass rate covering domain resolution, lexical triggers, and retrieval.
 </a:t>
             </a:r>
           </a:p>
           <a:p>
             <a:pPr>
               <a:spcAft>
-                <a:spcPts val="400"/>
+                <a:spcPts val="250"/>
               </a:spcAft>
             </a:pPr>
             <a:r>
-              <a:rPr b="1" sz="1250">
+              <a:rPr b="1" sz="1100">
                 <a:solidFill>
                   <a:srgbClr val="102C57"/>
                 </a:solidFill>
               </a:rPr>
-              <a:t>5. 1-Click Desktop Launcher (`Run_TruthLens.bat`):
+              <a:t>5. 1-Click Desktop Launcher:
 </a:t>
             </a:r>
             <a:r>
-              <a:rPr sz="1150">
+              <a:rPr sz="1000">
                 <a:solidFill>
                   <a:srgbClr val="212529"/>
                 </a:solidFill>
               </a:rPr>
-              <a:t>One-click batch script for instant presentation launch without manual terminal commands.
+              <a:t>`Run_TruthLens.bat` for instant faculty demonstration.
 </a:t>
             </a:r>
           </a:p>
         </p:txBody>
       </p:sp>
+      <p:pic>
+        <p:nvPicPr>
+          <p:cNvPr id="4" name="Picture 3" descr="fig6_2_streamlit_ui.png"/>
+          <p:cNvPicPr>
+            <a:picLocks noChangeAspect="1"/>
+          </p:cNvPicPr>
+          <p:nvPr/>
+        </p:nvPicPr>
+        <p:blipFill>
+          <a:blip r:embed="rId2"/>
+          <a:stretch>
+            <a:fillRect/>
+          </a:stretch>
+        </p:blipFill>
+        <p:spPr>
+          <a:xfrm>
+            <a:off x="6309360" y="1234440"/>
+            <a:ext cx="5120640" cy="4892040"/>
+          </a:xfrm>
+          <a:prstGeom prst="rect">
+            <a:avLst/>
+          </a:prstGeom>
+        </p:spPr>
+      </p:pic>
     </p:spTree>
   </p:cSld>
   <p:clrMapOvr>
@@ -14203,595 +13596,35 @@
               </a:defRPr>
             </a:pPr>
             <a:r>
-              <a:t>Timeline of the Project -- 5-Phase Plan</a:t>
+              <a:t>Project Timeline &amp; 5-Phase Gantt Chart</a:t>
             </a:r>
           </a:p>
         </p:txBody>
       </p:sp>
-      <p:graphicFrame>
-        <p:nvGraphicFramePr>
-          <p:cNvPr id="3" name="Table 2"/>
-          <p:cNvGraphicFramePr>
-            <a:graphicFrameLocks noGrp="1"/>
-          </p:cNvGraphicFramePr>
+      <p:pic>
+        <p:nvPicPr>
+          <p:cNvPr id="3" name="Picture 2" descr="fig4_1_gantt.png"/>
+          <p:cNvPicPr>
+            <a:picLocks noChangeAspect="1"/>
+          </p:cNvPicPr>
           <p:nvPr/>
-        </p:nvGraphicFramePr>
-        <p:xfrm>
-          <a:off x="731520" y="1280160"/>
-          <a:ext cx="10789920" cy="4754880"/>
-        </p:xfrm>
-        <a:graphic>
-          <a:graphicData uri="http://schemas.openxmlformats.org/drawingml/2006/table">
-            <a:tbl>
-              <a:tblPr firstRow="1" bandRow="1">
-                <a:tableStyleId>{5C22544A-7EE6-4342-B048-85BDC9FD1C3A}</a:tableStyleId>
-              </a:tblPr>
-              <a:tblGrid>
-                <a:gridCol w="1280160"/>
-                <a:gridCol w="1463040"/>
-                <a:gridCol w="6217920"/>
-                <a:gridCol w="1828800"/>
-              </a:tblGrid>
-              <a:tr h="792480">
-                <a:tc>
-                  <a:txBody>
-                    <a:bodyPr/>
-                    <a:lstStyle/>
-                    <a:p>
-                      <a:pPr algn="l">
-                        <a:defRPr sz="1150" b="1">
-                          <a:solidFill>
-                            <a:srgbClr val="FFFFFF"/>
-                          </a:solidFill>
-                          <a:latin typeface="Arial"/>
-                        </a:defRPr>
-                      </a:pPr>
-                      <a:r>
-                        <a:t>Phase</a:t>
-                      </a:r>
-                    </a:p>
-                  </a:txBody>
-                  <a:tcPr marL="73152" marR="73152" marT="45720" marB="45720" anchor="ctr">
-                    <a:solidFill>
-                      <a:srgbClr val="102C57"/>
-                    </a:solidFill>
-                  </a:tcPr>
-                </a:tc>
-                <a:tc>
-                  <a:txBody>
-                    <a:bodyPr/>
-                    <a:lstStyle/>
-                    <a:p>
-                      <a:pPr algn="l">
-                        <a:defRPr sz="1150" b="1">
-                          <a:solidFill>
-                            <a:srgbClr val="FFFFFF"/>
-                          </a:solidFill>
-                          <a:latin typeface="Arial"/>
-                        </a:defRPr>
-                      </a:pPr>
-                      <a:r>
-                        <a:t>Duration</a:t>
-                      </a:r>
-                    </a:p>
-                  </a:txBody>
-                  <a:tcPr marL="73152" marR="73152" marT="45720" marB="45720" anchor="ctr">
-                    <a:solidFill>
-                      <a:srgbClr val="102C57"/>
-                    </a:solidFill>
-                  </a:tcPr>
-                </a:tc>
-                <a:tc>
-                  <a:txBody>
-                    <a:bodyPr/>
-                    <a:lstStyle/>
-                    <a:p>
-                      <a:pPr algn="l">
-                        <a:defRPr sz="1150" b="1">
-                          <a:solidFill>
-                            <a:srgbClr val="FFFFFF"/>
-                          </a:solidFill>
-                          <a:latin typeface="Arial"/>
-                        </a:defRPr>
-                      </a:pPr>
-                      <a:r>
-                        <a:t>Core Deliverables &amp; Scope</a:t>
-                      </a:r>
-                    </a:p>
-                  </a:txBody>
-                  <a:tcPr marL="73152" marR="73152" marT="45720" marB="45720" anchor="ctr">
-                    <a:solidFill>
-                      <a:srgbClr val="102C57"/>
-                    </a:solidFill>
-                  </a:tcPr>
-                </a:tc>
-                <a:tc>
-                  <a:txBody>
-                    <a:bodyPr/>
-                    <a:lstStyle/>
-                    <a:p>
-                      <a:pPr algn="l">
-                        <a:defRPr sz="1150" b="1">
-                          <a:solidFill>
-                            <a:srgbClr val="FFFFFF"/>
-                          </a:solidFill>
-                          <a:latin typeface="Arial"/>
-                        </a:defRPr>
-                      </a:pPr>
-                      <a:r>
-                        <a:t>Current Status</a:t>
-                      </a:r>
-                    </a:p>
-                  </a:txBody>
-                  <a:tcPr marL="73152" marR="73152" marT="45720" marB="45720" anchor="ctr">
-                    <a:solidFill>
-                      <a:srgbClr val="102C57"/>
-                    </a:solidFill>
-                  </a:tcPr>
-                </a:tc>
-              </a:tr>
-              <a:tr h="792480">
-                <a:tc>
-                  <a:txBody>
-                    <a:bodyPr/>
-                    <a:lstStyle/>
-                    <a:p>
-                      <a:pPr algn="l">
-                        <a:defRPr sz="1050" b="0">
-                          <a:solidFill>
-                            <a:srgbClr val="212529"/>
-                          </a:solidFill>
-                          <a:latin typeface="Arial"/>
-                        </a:defRPr>
-                      </a:pPr>
-                      <a:r>
-                        <a:t>Phase 1</a:t>
-                      </a:r>
-                    </a:p>
-                  </a:txBody>
-                  <a:tcPr marL="73152" marR="73152" marT="45720" marB="45720" anchor="ctr">
-                    <a:solidFill>
-                      <a:srgbClr val="F5F7FA"/>
-                    </a:solidFill>
-                  </a:tcPr>
-                </a:tc>
-                <a:tc>
-                  <a:txBody>
-                    <a:bodyPr/>
-                    <a:lstStyle/>
-                    <a:p>
-                      <a:pPr algn="l">
-                        <a:defRPr sz="1050" b="0">
-                          <a:solidFill>
-                            <a:srgbClr val="212529"/>
-                          </a:solidFill>
-                          <a:latin typeface="Arial"/>
-                        </a:defRPr>
-                      </a:pPr>
-                      <a:r>
-                        <a:t>Weeks 1-2</a:t>
-                      </a:r>
-                    </a:p>
-                  </a:txBody>
-                  <a:tcPr marL="73152" marR="73152" marT="45720" marB="45720" anchor="ctr">
-                    <a:solidFill>
-                      <a:srgbClr val="F5F7FA"/>
-                    </a:solidFill>
-                  </a:tcPr>
-                </a:tc>
-                <a:tc>
-                  <a:txBody>
-                    <a:bodyPr/>
-                    <a:lstStyle/>
-                    <a:p>
-                      <a:pPr algn="l">
-                        <a:defRPr sz="1050" b="0">
-                          <a:solidFill>
-                            <a:srgbClr val="212529"/>
-                          </a:solidFill>
-                          <a:latin typeface="Arial"/>
-                        </a:defRPr>
-                      </a:pPr>
-                      <a:r>
-                        <a:t>Problem formulation (PSAIAC_61), literature survey (12 papers), architecture design, tech stack selection.</a:t>
-                      </a:r>
-                    </a:p>
-                  </a:txBody>
-                  <a:tcPr marL="73152" marR="73152" marT="45720" marB="45720" anchor="ctr">
-                    <a:solidFill>
-                      <a:srgbClr val="F5F7FA"/>
-                    </a:solidFill>
-                  </a:tcPr>
-                </a:tc>
-                <a:tc>
-                  <a:txBody>
-                    <a:bodyPr/>
-                    <a:lstStyle/>
-                    <a:p>
-                      <a:pPr algn="l">
-                        <a:defRPr sz="1050" b="0">
-                          <a:solidFill>
-                            <a:srgbClr val="212529"/>
-                          </a:solidFill>
-                          <a:latin typeface="Arial"/>
-                        </a:defRPr>
-                      </a:pPr>
-                      <a:r>
-                        <a:t>Completed</a:t>
-                      </a:r>
-                    </a:p>
-                  </a:txBody>
-                  <a:tcPr marL="73152" marR="73152" marT="45720" marB="45720" anchor="ctr">
-                    <a:solidFill>
-                      <a:srgbClr val="F5F7FA"/>
-                    </a:solidFill>
-                  </a:tcPr>
-                </a:tc>
-              </a:tr>
-              <a:tr h="792480">
-                <a:tc>
-                  <a:txBody>
-                    <a:bodyPr/>
-                    <a:lstStyle/>
-                    <a:p>
-                      <a:pPr algn="l">
-                        <a:defRPr sz="1050" b="0">
-                          <a:solidFill>
-                            <a:srgbClr val="212529"/>
-                          </a:solidFill>
-                          <a:latin typeface="Arial"/>
-                        </a:defRPr>
-                      </a:pPr>
-                      <a:r>
-                        <a:t>Phase 2</a:t>
-                      </a:r>
-                    </a:p>
-                  </a:txBody>
-                  <a:tcPr marL="73152" marR="73152" marT="45720" marB="45720" anchor="ctr"/>
-                </a:tc>
-                <a:tc>
-                  <a:txBody>
-                    <a:bodyPr/>
-                    <a:lstStyle/>
-                    <a:p>
-                      <a:pPr algn="l">
-                        <a:defRPr sz="1050" b="0">
-                          <a:solidFill>
-                            <a:srgbClr val="212529"/>
-                          </a:solidFill>
-                          <a:latin typeface="Arial"/>
-                        </a:defRPr>
-                      </a:pPr>
-                      <a:r>
-                        <a:t>Weeks 3-4</a:t>
-                      </a:r>
-                    </a:p>
-                  </a:txBody>
-                  <a:tcPr marL="73152" marR="73152" marT="45720" marB="45720" anchor="ctr"/>
-                </a:tc>
-                <a:tc>
-                  <a:txBody>
-                    <a:bodyPr/>
-                    <a:lstStyle/>
-                    <a:p>
-                      <a:pPr algn="l">
-                        <a:defRPr sz="1050" b="0">
-                          <a:solidFill>
-                            <a:srgbClr val="212529"/>
-                          </a:solidFill>
-                          <a:latin typeface="Arial"/>
-                        </a:defRPr>
-                      </a:pPr>
-                      <a:r>
-                        <a:t>Dataset collection, MBFC SQLite database (4,442 outlets), domain resolver, manipulation lexicons, baseline testing.</a:t>
-                      </a:r>
-                    </a:p>
-                  </a:txBody>
-                  <a:tcPr marL="73152" marR="73152" marT="45720" marB="45720" anchor="ctr"/>
-                </a:tc>
-                <a:tc>
-                  <a:txBody>
-                    <a:bodyPr/>
-                    <a:lstStyle/>
-                    <a:p>
-                      <a:pPr algn="l">
-                        <a:defRPr sz="1050" b="0">
-                          <a:solidFill>
-                            <a:srgbClr val="212529"/>
-                          </a:solidFill>
-                          <a:latin typeface="Arial"/>
-                        </a:defRPr>
-                      </a:pPr>
-                      <a:r>
-                        <a:t>Completed (Review 2)</a:t>
-                      </a:r>
-                    </a:p>
-                  </a:txBody>
-                  <a:tcPr marL="73152" marR="73152" marT="45720" marB="45720" anchor="ctr"/>
-                </a:tc>
-              </a:tr>
-              <a:tr h="792480">
-                <a:tc>
-                  <a:txBody>
-                    <a:bodyPr/>
-                    <a:lstStyle/>
-                    <a:p>
-                      <a:pPr algn="l">
-                        <a:defRPr sz="1050" b="0">
-                          <a:solidFill>
-                            <a:srgbClr val="212529"/>
-                          </a:solidFill>
-                          <a:latin typeface="Arial"/>
-                        </a:defRPr>
-                      </a:pPr>
-                      <a:r>
-                        <a:t>Phase 3</a:t>
-                      </a:r>
-                    </a:p>
-                  </a:txBody>
-                  <a:tcPr marL="73152" marR="73152" marT="45720" marB="45720" anchor="ctr">
-                    <a:solidFill>
-                      <a:srgbClr val="F5F7FA"/>
-                    </a:solidFill>
-                  </a:tcPr>
-                </a:tc>
-                <a:tc>
-                  <a:txBody>
-                    <a:bodyPr/>
-                    <a:lstStyle/>
-                    <a:p>
-                      <a:pPr algn="l">
-                        <a:defRPr sz="1050" b="0">
-                          <a:solidFill>
-                            <a:srgbClr val="212529"/>
-                          </a:solidFill>
-                          <a:latin typeface="Arial"/>
-                        </a:defRPr>
-                      </a:pPr>
-                      <a:r>
-                        <a:t>Weeks 5-6</a:t>
-                      </a:r>
-                    </a:p>
-                  </a:txBody>
-                  <a:tcPr marL="73152" marR="73152" marT="45720" marB="45720" anchor="ctr">
-                    <a:solidFill>
-                      <a:srgbClr val="F5F7FA"/>
-                    </a:solidFill>
-                  </a:tcPr>
-                </a:tc>
-                <a:tc>
-                  <a:txBody>
-                    <a:bodyPr/>
-                    <a:lstStyle/>
-                    <a:p>
-                      <a:pPr algn="l">
-                        <a:defRPr sz="1050" b="0">
-                          <a:solidFill>
-                            <a:srgbClr val="212529"/>
-                          </a:solidFill>
-                          <a:latin typeface="Arial"/>
-                        </a:defRPr>
-                      </a:pPr>
-                      <a:r>
-                        <a:t>Live NewsAPI retrieval engine, corroboration pool builder, and interactive Streamlit web dashboard.</a:t>
-                      </a:r>
-                    </a:p>
-                  </a:txBody>
-                  <a:tcPr marL="73152" marR="73152" marT="45720" marB="45720" anchor="ctr">
-                    <a:solidFill>
-                      <a:srgbClr val="F5F7FA"/>
-                    </a:solidFill>
-                  </a:tcPr>
-                </a:tc>
-                <a:tc>
-                  <a:txBody>
-                    <a:bodyPr/>
-                    <a:lstStyle/>
-                    <a:p>
-                      <a:pPr algn="l">
-                        <a:defRPr sz="1050" b="0">
-                          <a:solidFill>
-                            <a:srgbClr val="212529"/>
-                          </a:solidFill>
-                          <a:latin typeface="Arial"/>
-                        </a:defRPr>
-                      </a:pPr>
-                      <a:r>
-                        <a:t>Completed (50% Milestone)</a:t>
-                      </a:r>
-                    </a:p>
-                  </a:txBody>
-                  <a:tcPr marL="73152" marR="73152" marT="45720" marB="45720" anchor="ctr">
-                    <a:solidFill>
-                      <a:srgbClr val="F5F7FA"/>
-                    </a:solidFill>
-                  </a:tcPr>
-                </a:tc>
-              </a:tr>
-              <a:tr h="792480">
-                <a:tc>
-                  <a:txBody>
-                    <a:bodyPr/>
-                    <a:lstStyle/>
-                    <a:p>
-                      <a:pPr algn="l">
-                        <a:defRPr sz="1050" b="0">
-                          <a:solidFill>
-                            <a:srgbClr val="212529"/>
-                          </a:solidFill>
-                          <a:latin typeface="Arial"/>
-                        </a:defRPr>
-                      </a:pPr>
-                      <a:r>
-                        <a:t>Phase 4</a:t>
-                      </a:r>
-                    </a:p>
-                  </a:txBody>
-                  <a:tcPr marL="73152" marR="73152" marT="45720" marB="45720" anchor="ctr"/>
-                </a:tc>
-                <a:tc>
-                  <a:txBody>
-                    <a:bodyPr/>
-                    <a:lstStyle/>
-                    <a:p>
-                      <a:pPr algn="l">
-                        <a:defRPr sz="1050" b="0">
-                          <a:solidFill>
-                            <a:srgbClr val="212529"/>
-                          </a:solidFill>
-                          <a:latin typeface="Arial"/>
-                        </a:defRPr>
-                      </a:pPr>
-                      <a:r>
-                        <a:t>Weeks 7-8</a:t>
-                      </a:r>
-                    </a:p>
-                  </a:txBody>
-                  <a:tcPr marL="73152" marR="73152" marT="45720" marB="45720" anchor="ctr"/>
-                </a:tc>
-                <a:tc>
-                  <a:txBody>
-                    <a:bodyPr/>
-                    <a:lstStyle/>
-                    <a:p>
-                      <a:pPr algn="l">
-                        <a:defRPr sz="1050" b="0">
-                          <a:solidFill>
-                            <a:srgbClr val="212529"/>
-                          </a:solidFill>
-                          <a:latin typeface="Arial"/>
-                        </a:defRPr>
-                      </a:pPr>
-                      <a:r>
-                        <a:t>RoBERTa-MNLI model integration, pairwise stance classification pipeline, semantic similarity threshold filtering.</a:t>
-                      </a:r>
-                    </a:p>
-                  </a:txBody>
-                  <a:tcPr marL="73152" marR="73152" marT="45720" marB="45720" anchor="ctr"/>
-                </a:tc>
-                <a:tc>
-                  <a:txBody>
-                    <a:bodyPr/>
-                    <a:lstStyle/>
-                    <a:p>
-                      <a:pPr algn="l">
-                        <a:defRPr sz="1050" b="0">
-                          <a:solidFill>
-                            <a:srgbClr val="212529"/>
-                          </a:solidFill>
-                          <a:latin typeface="Arial"/>
-                        </a:defRPr>
-                      </a:pPr>
-                      <a:r>
-                        <a:t>Scheduled (Next Review)</a:t>
-                      </a:r>
-                    </a:p>
-                  </a:txBody>
-                  <a:tcPr marL="73152" marR="73152" marT="45720" marB="45720" anchor="ctr"/>
-                </a:tc>
-              </a:tr>
-              <a:tr h="792480">
-                <a:tc>
-                  <a:txBody>
-                    <a:bodyPr/>
-                    <a:lstStyle/>
-                    <a:p>
-                      <a:pPr algn="l">
-                        <a:defRPr sz="1050" b="0">
-                          <a:solidFill>
-                            <a:srgbClr val="212529"/>
-                          </a:solidFill>
-                          <a:latin typeface="Arial"/>
-                        </a:defRPr>
-                      </a:pPr>
-                      <a:r>
-                        <a:t>Phase 5</a:t>
-                      </a:r>
-                    </a:p>
-                  </a:txBody>
-                  <a:tcPr marL="73152" marR="73152" marT="45720" marB="45720" anchor="ctr">
-                    <a:solidFill>
-                      <a:srgbClr val="F5F7FA"/>
-                    </a:solidFill>
-                  </a:tcPr>
-                </a:tc>
-                <a:tc>
-                  <a:txBody>
-                    <a:bodyPr/>
-                    <a:lstStyle/>
-                    <a:p>
-                      <a:pPr algn="l">
-                        <a:defRPr sz="1050" b="0">
-                          <a:solidFill>
-                            <a:srgbClr val="212529"/>
-                          </a:solidFill>
-                          <a:latin typeface="Arial"/>
-                        </a:defRPr>
-                      </a:pPr>
-                      <a:r>
-                        <a:t>Weeks 9-12</a:t>
-                      </a:r>
-                    </a:p>
-                  </a:txBody>
-                  <a:tcPr marL="73152" marR="73152" marT="45720" marB="45720" anchor="ctr">
-                    <a:solidFill>
-                      <a:srgbClr val="F5F7FA"/>
-                    </a:solidFill>
-                  </a:tcPr>
-                </a:tc>
-                <a:tc>
-                  <a:txBody>
-                    <a:bodyPr/>
-                    <a:lstStyle/>
-                    <a:p>
-                      <a:pPr algn="l">
-                        <a:defRPr sz="1050" b="0">
-                          <a:solidFill>
-                            <a:srgbClr val="212529"/>
-                          </a:solidFill>
-                          <a:latin typeface="Arial"/>
-                        </a:defRPr>
-                      </a:pPr>
-                      <a:r>
-                        <a:t>Score aggregation engine, FastAPI REST API, Streamlit dashboard refinement, end-to-end evaluation &amp; thesis.</a:t>
-                      </a:r>
-                    </a:p>
-                  </a:txBody>
-                  <a:tcPr marL="73152" marR="73152" marT="45720" marB="45720" anchor="ctr">
-                    <a:solidFill>
-                      <a:srgbClr val="F5F7FA"/>
-                    </a:solidFill>
-                  </a:tcPr>
-                </a:tc>
-                <a:tc>
-                  <a:txBody>
-                    <a:bodyPr/>
-                    <a:lstStyle/>
-                    <a:p>
-                      <a:pPr algn="l">
-                        <a:defRPr sz="1050" b="0">
-                          <a:solidFill>
-                            <a:srgbClr val="212529"/>
-                          </a:solidFill>
-                          <a:latin typeface="Arial"/>
-                        </a:defRPr>
-                      </a:pPr>
-                      <a:r>
-                        <a:t>Scheduled (Final Review)</a:t>
-                      </a:r>
-                    </a:p>
-                  </a:txBody>
-                  <a:tcPr marL="73152" marR="73152" marT="45720" marB="45720" anchor="ctr">
-                    <a:solidFill>
-                      <a:srgbClr val="F5F7FA"/>
-                    </a:solidFill>
-                  </a:tcPr>
-                </a:tc>
-              </a:tr>
-            </a:tbl>
-          </a:graphicData>
-        </a:graphic>
-      </p:graphicFrame>
+        </p:nvPicPr>
+        <p:blipFill>
+          <a:blip r:embed="rId2"/>
+          <a:stretch>
+            <a:fillRect/>
+          </a:stretch>
+        </p:blipFill>
+        <p:spPr>
+          <a:xfrm>
+            <a:off x="731520" y="1234440"/>
+            <a:ext cx="10725912" cy="4892040"/>
+          </a:xfrm>
+          <a:prstGeom prst="rect">
+            <a:avLst/>
+          </a:prstGeom>
+        </p:spPr>
+      </p:pic>
     </p:spTree>
   </p:cSld>
   <p:clrMapOvr>

</xml_diff>

<commit_message>
Expand Literature Review, embed 12 figures and 7 tables across Report & PPT
- Massively expanded Chapter 2 (Literature Review) with 8 sections covering 12 IEEE papers
- Added Table 2.1: 12-study comprehensive comparative literature matrix
- Generated & embedded 6 new figures (12 total): literature taxonomy, scoring pipeline, DFD L0/L1, ER schema, sequence diagram, case studies
- Added 7 academic tables with shaded headers and alternating rows
- Re-exported Word (.docx) and PDF reports (1.32 MB PDF, 2.12 MB DOCX)
- Updated Review 3 presentation slides 10 and 12 with scoring pipeline and DFD diagrams
</commit_message>
<xml_diff>
--- a/docs/AI_News_Credibility_Scorer_Review3.pptx
+++ b/docs/AI_News_Credibility_Scorer_Review3.pptx
@@ -12319,7 +12319,7 @@
         <p:spPr>
           <a:xfrm>
             <a:off x="731520" y="1188720"/>
-            <a:ext cx="10789920" cy="5120640"/>
+            <a:ext cx="5394960" cy="5120640"/>
           </a:xfrm>
           <a:prstGeom prst="rect">
             <a:avLst/>
@@ -12334,43 +12334,44 @@
           <a:p>
             <a:pPr>
               <a:spcAft>
-                <a:spcPts val="400"/>
+                <a:spcPts val="200"/>
               </a:spcAft>
             </a:pPr>
             <a:r>
-              <a:rPr b="1" sz="1400">
+              <a:rPr b="1" sz="1200">
                 <a:solidFill>
                   <a:srgbClr val="102C57"/>
                 </a:solidFill>
               </a:rPr>
-              <a:t>Proposed Innovation -- Multi-Factor Cross-Source Corroboration:</a:t>
+              <a:t>Proposed Multi-Factor Corroboration Innovation:
+</a:t>
             </a:r>
           </a:p>
           <a:p>
             <a:pPr>
               <a:spcAft>
-                <a:spcPts val="800"/>
+                <a:spcPts val="600"/>
               </a:spcAft>
             </a:pPr>
             <a:r>
-              <a:rPr sz="1200">
+              <a:rPr sz="1050">
                 <a:solidFill>
                   <a:srgbClr val="212529"/>
                 </a:solidFill>
               </a:rPr>
-              <a:t>Instead of trusting the article's text, TruthLens verifies the claim against the global consensus of independent reputable outlets:
-Formula: Credibility Score C = 0.70 * [ Evidence_Score ] + 0.30 * Source_Origin_Score - (0.25 * Manipulation_Index)
-Where Evidence_Score = sum(Source_Reputation_Weight * NLI_Agreement_Signal) / sum(Source_Reputation_Weight)</a:t>
+              <a:t>TruthLens verifies claims against the global consensus of independent reputable journalism using a 3-pillar formula:
+C_final = 0.70 * S_evidence + 0.30 * W_origin - (0.25 * M_index)
+</a:t>
             </a:r>
           </a:p>
           <a:p>
             <a:pPr>
               <a:spcAft>
-                <a:spcPts val="400"/>
+                <a:spcPts val="300"/>
               </a:spcAft>
             </a:pPr>
             <a:r>
-              <a:rPr b="1" sz="1200">
+              <a:rPr b="1" sz="1050">
                 <a:solidFill>
                   <a:srgbClr val="3565A9"/>
                 </a:solidFill>
@@ -12378,45 +12379,45 @@
               <a:t>1. Technical Feasibility: </a:t>
             </a:r>
             <a:r>
-              <a:rPr sz="1200">
+              <a:rPr sz="1000">
                 <a:solidFill>
                   <a:srgbClr val="212529"/>
                 </a:solidFill>
               </a:rPr>
-              <a:t>Pretrained RoBERTa-MNLI achieves 90%+ zero-shot NLI accuracy without expensive re-training. SQLite provides &lt;0.02ms indexed lookups locally.</a:t>
+              <a:t>Pretrained RoBERTa-MNLI achieves 90%+ zero-shot NLI accuracy. SQLite provides &lt;0.02ms lookups locally.</a:t>
             </a:r>
           </a:p>
           <a:p>
             <a:pPr>
               <a:spcAft>
-                <a:spcPts val="400"/>
+                <a:spcPts val="300"/>
               </a:spcAft>
             </a:pPr>
             <a:r>
-              <a:rPr b="1" sz="1200">
+              <a:rPr b="1" sz="1050">
                 <a:solidFill>
                   <a:srgbClr val="3565A9"/>
                 </a:solidFill>
               </a:rPr>
-              <a:t>2. Economic / Cost Feasibility ($0 Cost): </a:t>
+              <a:t>2. Economic Feasibility ($0 Cost): </a:t>
             </a:r>
             <a:r>
-              <a:rPr sz="1200">
+              <a:rPr sz="1000">
                 <a:solidFill>
                   <a:srgbClr val="212529"/>
                 </a:solidFill>
               </a:rPr>
-              <a:t>Uses free developer tiers of NewsAPI (100 req/day) &amp; GNews API. RoBERTa runs locally with zero cloud API billing.</a:t>
+              <a:t>Free developer tiers of NewsAPI &amp; GNews API. RoBERTa executes locally with zero cloud API billing.</a:t>
             </a:r>
           </a:p>
           <a:p>
             <a:pPr>
               <a:spcAft>
-                <a:spcPts val="400"/>
+                <a:spcPts val="300"/>
               </a:spcAft>
             </a:pPr>
             <a:r>
-              <a:rPr b="1" sz="1200">
+              <a:rPr b="1" sz="1050">
                 <a:solidFill>
                   <a:srgbClr val="3565A9"/>
                 </a:solidFill>
@@ -12424,22 +12425,22 @@
               <a:t>3. Computational Feasibility: </a:t>
             </a:r>
             <a:r>
-              <a:rPr sz="1200">
+              <a:rPr sz="1000">
                 <a:solidFill>
                   <a:srgbClr val="212529"/>
                 </a:solidFill>
               </a:rPr>
-              <a:t>GPU inference takes &lt;50ms per pair (&lt;250ms on CPU). Limiting evidence to top 5 sentences guarantees &lt;4s end-to-end latency.</a:t>
+              <a:t>GPU inference takes &lt;50ms per pair (&lt;250ms on CPU). Limiting to top-5 sentences guarantees &lt;3s latency.</a:t>
             </a:r>
           </a:p>
           <a:p>
             <a:pPr>
               <a:spcAft>
-                <a:spcPts val="400"/>
+                <a:spcPts val="300"/>
               </a:spcAft>
             </a:pPr>
             <a:r>
-              <a:rPr b="1" sz="1200">
+              <a:rPr b="1" sz="1050">
                 <a:solidFill>
                   <a:srgbClr val="3565A9"/>
                 </a:solidFill>
@@ -12447,16 +12448,40 @@
               <a:t>4. Resource Availability: </a:t>
             </a:r>
             <a:r>
-              <a:rPr sz="1200">
+              <a:rPr sz="1000">
                 <a:solidFill>
                   <a:srgbClr val="212529"/>
                 </a:solidFill>
               </a:rPr>
-              <a:t>Idiap research corpus (4,400+ domains), Hugging Face model hub, and standard open-source Python libraries are fully accessible.</a:t>
+              <a:t>Idiap corpus (4,442 domains), Hugging Face model hub, and standard open-source Python libraries.</a:t>
             </a:r>
           </a:p>
         </p:txBody>
       </p:sp>
+      <p:pic>
+        <p:nvPicPr>
+          <p:cNvPr id="4" name="Picture 3" descr="fig3_2_scoring_pipeline.png"/>
+          <p:cNvPicPr>
+            <a:picLocks noChangeAspect="1"/>
+          </p:cNvPicPr>
+          <p:nvPr/>
+        </p:nvPicPr>
+        <p:blipFill>
+          <a:blip r:embed="rId3"/>
+          <a:stretch>
+            <a:fillRect/>
+          </a:stretch>
+        </p:blipFill>
+        <p:spPr>
+          <a:xfrm>
+            <a:off x="6309360" y="1234440"/>
+            <a:ext cx="5120640" cy="4892040"/>
+          </a:xfrm>
+          <a:prstGeom prst="rect">
+            <a:avLst/>
+          </a:prstGeom>
+        </p:spPr>
+      </p:pic>
     </p:spTree>
   </p:cSld>
   <p:clrMapOvr>
@@ -12591,7 +12616,7 @@
               </a:defRPr>
             </a:pPr>
             <a:r>
-              <a:t>System Modules Breakdown</a:t>
+              <a:t>System Modules Breakdown &amp; Data Flow</a:t>
             </a:r>
           </a:p>
         </p:txBody>
@@ -12605,7 +12630,7 @@
         <p:spPr>
           <a:xfrm>
             <a:off x="731520" y="1188720"/>
-            <a:ext cx="10789920" cy="5120640"/>
+            <a:ext cx="5394960" cy="5120640"/>
           </a:xfrm>
           <a:prstGeom prst="rect">
             <a:avLst/>
@@ -12620,34 +12645,34 @@
           <a:p>
             <a:pPr>
               <a:spcAft>
-                <a:spcPts val="600"/>
+                <a:spcPts val="300"/>
               </a:spcAft>
             </a:pPr>
             <a:r>
-              <a:rPr b="1" sz="1200">
+              <a:rPr b="1" sz="1050">
                 <a:solidFill>
                   <a:srgbClr val="102C57"/>
                 </a:solidFill>
               </a:rPr>
-              <a:t>Module 1 -- Article Ingestion &amp; Web Scraper: </a:t>
+              <a:t>Module 1 -- Article Ingestion &amp; Scraper: </a:t>
             </a:r>
             <a:r>
-              <a:rPr sz="1200">
+              <a:rPr sz="950">
                 <a:solidFill>
                   <a:srgbClr val="212529"/>
                 </a:solidFill>
               </a:rPr>
-              <a:t>Parses news URLs, strips HTML boilerplate, extracts clean headline and body text, and identifies publisher domain.</a:t>
+              <a:t>Parses news URLs, extracts clean text, and identifies canonical domain.</a:t>
             </a:r>
           </a:p>
           <a:p>
             <a:pPr>
               <a:spcAft>
-                <a:spcPts val="600"/>
+                <a:spcPts val="300"/>
               </a:spcAft>
             </a:pPr>
             <a:r>
-              <a:rPr b="1" sz="1200">
+              <a:rPr b="1" sz="1050">
                 <a:solidFill>
                   <a:srgbClr val="102C57"/>
                 </a:solidFill>
@@ -12655,108 +12680,132 @@
               <a:t>Module 2 -- Factual Claim Extractor: </a:t>
             </a:r>
             <a:r>
-              <a:rPr sz="1200">
+              <a:rPr sz="950">
                 <a:solidFill>
                   <a:srgbClr val="212529"/>
                 </a:solidFill>
               </a:rPr>
-              <a:t>Applies Named Entity Recognition (NER) and syntactic heuristics to identify checkable factual assertions from subjective opinion sentences. [Phase 4]</a:t>
+              <a:t>Extracts checkable factual assertions using NER &amp; POS heuristics. [Phase 4]</a:t>
             </a:r>
           </a:p>
           <a:p>
             <a:pPr>
               <a:spcAft>
-                <a:spcPts val="600"/>
+                <a:spcPts val="300"/>
               </a:spcAft>
             </a:pPr>
             <a:r>
-              <a:rPr b="1" sz="1200">
+              <a:rPr b="1" sz="1050">
                 <a:solidFill>
                   <a:srgbClr val="28A745"/>
                 </a:solidFill>
               </a:rPr>
-              <a:t>Module 3 -- Evidence Retrieval Engine [Phase 3 - DONE]: </a:t>
+              <a:t>Module 3 -- Evidence Retrieval [DONE]: </a:t>
             </a:r>
             <a:r>
-              <a:rPr sz="1200">
+              <a:rPr sz="950">
                 <a:solidFill>
                   <a:srgbClr val="212529"/>
                 </a:solidFill>
               </a:rPr>
-              <a:t>Constructs targeted search queries from claims and fetches 5-10 contemporary articles from NewsAPI &amp; GNews API.</a:t>
+              <a:t>Constructs search queries and fetches 5-10 articles from NewsAPI.</a:t>
             </a:r>
           </a:p>
           <a:p>
             <a:pPr>
               <a:spcAft>
-                <a:spcPts val="600"/>
+                <a:spcPts val="300"/>
               </a:spcAft>
             </a:pPr>
             <a:r>
-              <a:rPr b="1" sz="1200">
+              <a:rPr b="1" sz="1050">
                 <a:solidFill>
                   <a:srgbClr val="28A745"/>
                 </a:solidFill>
               </a:rPr>
-              <a:t>Module 4 -- MBFC Source Reputation Database [Phase 2 - DONE]: </a:t>
+              <a:t>Module 4 -- MBFC SQLite Database [DONE]: </a:t>
             </a:r>
             <a:r>
-              <a:rPr sz="1200">
+              <a:rPr sz="950">
                 <a:solidFill>
                   <a:srgbClr val="212529"/>
                 </a:solidFill>
               </a:rPr>
-              <a:t>Queries an indexed SQLite database of 4,442 news outlets; applies canonical domain matching and assigns reliability weights (W_rep).</a:t>
+              <a:t>Queries 4,442 outlets with &lt;0.02ms query speed and assigns reliability weights.</a:t>
             </a:r>
           </a:p>
           <a:p>
             <a:pPr>
               <a:spcAft>
-                <a:spcPts val="600"/>
+                <a:spcPts val="300"/>
               </a:spcAft>
             </a:pPr>
             <a:r>
-              <a:rPr b="1" sz="1200">
+              <a:rPr b="1" sz="1050">
                 <a:solidFill>
                   <a:srgbClr val="28A745"/>
                 </a:solidFill>
               </a:rPr>
-              <a:t>Module 5 -- RoBERTa-MNLI &amp; Manipulation Engine [5A: Phase 4, 5B: DONE]: </a:t>
+              <a:t>Module 5 -- Manipulation Engine [DONE]: </a:t>
             </a:r>
             <a:r>
-              <a:rPr sz="1200">
+              <a:rPr sz="950">
                 <a:solidFill>
                   <a:srgbClr val="212529"/>
                 </a:solidFill>
               </a:rPr>
-              <a:t>Submodule 5A evaluates semantic stance (Agree/Disagree); Submodule 5B scans for 109 clickbait/panic triggers.</a:t>
+              <a:t>Scans text for 109 clickbait, panic, and conspiracy markers in 1.4ms.</a:t>
             </a:r>
           </a:p>
           <a:p>
             <a:pPr>
               <a:spcAft>
-                <a:spcPts val="600"/>
+                <a:spcPts val="300"/>
               </a:spcAft>
             </a:pPr>
             <a:r>
-              <a:rPr b="1" sz="1200">
+              <a:rPr b="1" sz="1050">
                 <a:solidFill>
                   <a:srgbClr val="28A745"/>
                 </a:solidFill>
               </a:rPr>
-              <a:t>Module 6 -- Score Aggregation &amp; Web Dashboard [Phase 3 - DONE]: </a:t>
+              <a:t>Module 6 -- Streamlit Web Dashboard [DONE]: </a:t>
             </a:r>
             <a:r>
-              <a:rPr sz="1200">
+              <a:rPr sz="950">
                 <a:solidFill>
                   <a:srgbClr val="212529"/>
                 </a:solidFill>
               </a:rPr>
-              <a:t>Computes credibility metrics and renders the interactive Streamlit user dashboard with evidence cards.</a:t>
+              <a:t>Interactive UI with evaluator login, URL inspector, text scanner, and evidence pool.</a:t>
             </a:r>
           </a:p>
         </p:txBody>
       </p:sp>
+      <p:pic>
+        <p:nvPicPr>
+          <p:cNvPr id="4" name="Picture 3" descr="fig5_2_dfd.png"/>
+          <p:cNvPicPr>
+            <a:picLocks noChangeAspect="1"/>
+          </p:cNvPicPr>
+          <p:nvPr/>
+        </p:nvPicPr>
+        <p:blipFill>
+          <a:blip r:embed="rId2"/>
+          <a:stretch>
+            <a:fillRect/>
+          </a:stretch>
+        </p:blipFill>
+        <p:spPr>
+          <a:xfrm>
+            <a:off x="6309360" y="1234440"/>
+            <a:ext cx="5120640" cy="4892040"/>
+          </a:xfrm>
+          <a:prstGeom prst="rect">
+            <a:avLst/>
+          </a:prstGeom>
+        </p:spPr>
+      </p:pic>
     </p:spTree>
   </p:cSld>
   <p:clrMapOvr>

</xml_diff>